<commit_message>
Enlarge terms-card desc and break on period (sessions 11-22)
Bump desc font 13->16pt and split each desc on '。' so cards show
2-3 short paragraphs instead of one runon line. Card height 2.7->3.3in
to absorb the bigger text. Regenerate sessions 11-22 only; sessions
9-10 keep the previous layout per request.

https://claude.ai/code/session_01MLnStsm4YQNeGye3rc2BGH
</commit_message>
<xml_diff>
--- a/lecture_pptx/out/s11/ワーク01.pptx
+++ b/lecture_pptx/out/s11/ワーク01.pptx
@@ -2279,7 +2279,7 @@
         <p:spPr>
           <a:xfrm>
             <a:off x="365760" y="1188720"/>
-            <a:ext cx="1979676" cy="2468880"/>
+            <a:ext cx="1979676" cy="3017520"/>
           </a:xfrm>
           <a:prstGeom prst="roundRect">
             <a:avLst>
@@ -2386,8 +2386,8 @@
         </p:nvSpPr>
         <p:spPr>
           <a:xfrm>
-            <a:off x="530352" y="1901952"/>
-            <a:ext cx="1650492" cy="1645920"/>
+            <a:off x="530352" y="1938528"/>
+            <a:ext cx="1650492" cy="2148840"/>
           </a:xfrm>
           <a:prstGeom prst="rect">
             <a:avLst/>
@@ -2401,12 +2401,12 @@
           <a:p>
             <a:pPr indent="0" marL="0">
               <a:spcAft>
-                <a:spcPts val="200"/>
+                <a:spcPts val="600"/>
               </a:spcAft>
               <a:buNone/>
             </a:pPr>
             <a:r>
-              <a:rPr lang="en-US" sz="1300" dirty="0">
+              <a:rPr lang="en-US" sz="1600" dirty="0">
                 <a:solidFill>
                   <a:srgbClr val="1A1A1A"/>
                 </a:solidFill>
@@ -2414,9 +2414,26 @@
                 <a:ea typeface="Yu Gothic UI" pitchFamily="34" charset="-122"/>
                 <a:cs typeface="Yu Gothic UI" pitchFamily="34" charset="-120"/>
               </a:rPr>
-              <a:t>友だちが商品/サービスへの関心度合い。配信反応や登録経路で推定する。</a:t>
-            </a:r>
-            <a:endParaRPr lang="en-US" sz="1300" dirty="0"/>
+              <a:t>友だちが商品/サービスへの関心度合い。</a:t>
+            </a:r>
+            <a:pPr indent="0" marL="0">
+              <a:spcAft>
+                <a:spcPts val="600"/>
+              </a:spcAft>
+              <a:buNone/>
+            </a:pPr>
+            <a:r>
+              <a:rPr lang="en-US" sz="1600" dirty="0">
+                <a:solidFill>
+                  <a:srgbClr val="1A1A1A"/>
+                </a:solidFill>
+                <a:latin typeface="Yu Gothic UI" pitchFamily="34" charset="0"/>
+                <a:ea typeface="Yu Gothic UI" pitchFamily="34" charset="-122"/>
+                <a:cs typeface="Yu Gothic UI" pitchFamily="34" charset="-120"/>
+              </a:rPr>
+              <a:t>配信反応や登録経路で推定する。</a:t>
+            </a:r>
+            <a:endParaRPr lang="en-US" sz="1600" dirty="0"/>
           </a:p>
         </p:txBody>
       </p:sp>
@@ -2429,7 +2446,7 @@
         <p:spPr>
           <a:xfrm>
             <a:off x="2510028" y="1188720"/>
-            <a:ext cx="1979676" cy="2468880"/>
+            <a:ext cx="1979676" cy="3017520"/>
           </a:xfrm>
           <a:prstGeom prst="roundRect">
             <a:avLst>
@@ -2536,8 +2553,8 @@
         </p:nvSpPr>
         <p:spPr>
           <a:xfrm>
-            <a:off x="2674620" y="1901952"/>
-            <a:ext cx="1650492" cy="1645920"/>
+            <a:off x="2674620" y="1938528"/>
+            <a:ext cx="1650492" cy="2148840"/>
           </a:xfrm>
           <a:prstGeom prst="rect">
             <a:avLst/>
@@ -2551,12 +2568,12 @@
           <a:p>
             <a:pPr indent="0" marL="0">
               <a:spcAft>
-                <a:spcPts val="200"/>
+                <a:spcPts val="600"/>
               </a:spcAft>
               <a:buNone/>
             </a:pPr>
             <a:r>
-              <a:rPr lang="en-US" sz="1300" dirty="0">
+              <a:rPr lang="en-US" sz="1600" dirty="0">
                 <a:solidFill>
                   <a:srgbClr val="1A1A1A"/>
                 </a:solidFill>
@@ -2566,7 +2583,7 @@
               </a:rPr>
               <a:t>何日目に何を見せて、最終的にどんな行動を促すかの計画。</a:t>
             </a:r>
-            <a:endParaRPr lang="en-US" sz="1300" dirty="0"/>
+            <a:endParaRPr lang="en-US" sz="1600" dirty="0"/>
           </a:p>
         </p:txBody>
       </p:sp>
@@ -2579,7 +2596,7 @@
         <p:spPr>
           <a:xfrm>
             <a:off x="4654296" y="1188720"/>
-            <a:ext cx="1979676" cy="2468880"/>
+            <a:ext cx="1979676" cy="3017520"/>
           </a:xfrm>
           <a:prstGeom prst="roundRect">
             <a:avLst>
@@ -2686,8 +2703,8 @@
         </p:nvSpPr>
         <p:spPr>
           <a:xfrm>
-            <a:off x="4818888" y="1901952"/>
-            <a:ext cx="1650492" cy="1645920"/>
+            <a:off x="4818888" y="1938528"/>
+            <a:ext cx="1650492" cy="2148840"/>
           </a:xfrm>
           <a:prstGeom prst="rect">
             <a:avLst/>
@@ -2701,12 +2718,12 @@
           <a:p>
             <a:pPr indent="0" marL="0">
               <a:spcAft>
-                <a:spcPts val="200"/>
+                <a:spcPts val="600"/>
               </a:spcAft>
               <a:buNone/>
             </a:pPr>
             <a:r>
-              <a:rPr lang="en-US" sz="1300" dirty="0">
+              <a:rPr lang="en-US" sz="1600" dirty="0">
                 <a:solidFill>
                   <a:srgbClr val="1A1A1A"/>
                 </a:solidFill>
@@ -2716,7 +2733,7 @@
               </a:rPr>
               <a:t>友だち1人1人に合わせて配信内容を変える工夫。</a:t>
             </a:r>
-            <a:endParaRPr lang="en-US" sz="1300" dirty="0"/>
+            <a:endParaRPr lang="en-US" sz="1600" dirty="0"/>
           </a:p>
         </p:txBody>
       </p:sp>
@@ -2729,7 +2746,7 @@
         <p:spPr>
           <a:xfrm>
             <a:off x="6798564" y="1188720"/>
-            <a:ext cx="1979676" cy="2468880"/>
+            <a:ext cx="1979676" cy="3017520"/>
           </a:xfrm>
           <a:prstGeom prst="roundRect">
             <a:avLst>
@@ -2836,8 +2853,8 @@
         </p:nvSpPr>
         <p:spPr>
           <a:xfrm>
-            <a:off x="6963156" y="1901952"/>
-            <a:ext cx="1650492" cy="1645920"/>
+            <a:off x="6963156" y="1938528"/>
+            <a:ext cx="1650492" cy="2148840"/>
           </a:xfrm>
           <a:prstGeom prst="rect">
             <a:avLst/>
@@ -2851,12 +2868,12 @@
           <a:p>
             <a:pPr indent="0" marL="0">
               <a:spcAft>
-                <a:spcPts val="200"/>
+                <a:spcPts val="600"/>
               </a:spcAft>
               <a:buNone/>
             </a:pPr>
             <a:r>
-              <a:rPr lang="en-US" sz="1300" dirty="0">
+              <a:rPr lang="en-US" sz="1600" dirty="0">
                 <a:solidFill>
                   <a:srgbClr val="1A1A1A"/>
                 </a:solidFill>
@@ -2864,9 +2881,26 @@
                 <a:ea typeface="Yu Gothic UI" pitchFamily="34" charset="-122"/>
                 <a:cs typeface="Yu Gothic UI" pitchFamily="34" charset="-120"/>
               </a:rPr>
-              <a:t>配信目的を達成した状態。予約・問合せ・資料請求など。</a:t>
-            </a:r>
-            <a:endParaRPr lang="en-US" sz="1300" dirty="0"/>
+              <a:t>配信目的を達成した状態。</a:t>
+            </a:r>
+            <a:pPr indent="0" marL="0">
+              <a:spcAft>
+                <a:spcPts val="600"/>
+              </a:spcAft>
+              <a:buNone/>
+            </a:pPr>
+            <a:r>
+              <a:rPr lang="en-US" sz="1600" dirty="0">
+                <a:solidFill>
+                  <a:srgbClr val="1A1A1A"/>
+                </a:solidFill>
+                <a:latin typeface="Yu Gothic UI" pitchFamily="34" charset="0"/>
+                <a:ea typeface="Yu Gothic UI" pitchFamily="34" charset="-122"/>
+                <a:cs typeface="Yu Gothic UI" pitchFamily="34" charset="-120"/>
+              </a:rPr>
+              <a:t>予約・問合せ・資料請求など。</a:t>
+            </a:r>
+            <a:endParaRPr lang="en-US" sz="1600" dirty="0"/>
           </a:p>
         </p:txBody>
       </p:sp>
@@ -2878,8 +2912,8 @@
         </p:nvSpPr>
         <p:spPr>
           <a:xfrm>
-            <a:off x="365760" y="3931920"/>
-            <a:ext cx="8412480" cy="1188720"/>
+            <a:off x="365760" y="4389120"/>
+            <a:ext cx="8412480" cy="914400"/>
           </a:xfrm>
           <a:prstGeom prst="rect">
             <a:avLst/>

</xml_diff>

<commit_message>
Rework session 11 as LINE rich-menu chatbot via GAS (insurance)
Replace the tag-and-scenario walkthrough with a hands-on build of a
GAS-powered chatbot wired to the public LINE rich menu, framed for
insurance sales. ワーク01 covers designing the button-driven
conversation flow and standing up the Messaging-API webhook in GAS.
ワーク02 layers Gemini API for natural replies, embeds a company FAQ
via system prompt or Gem knowledge, and adds a [HANDOFF] path that
emails a human advisor when the AI decides the request is out of
scope. Modeled on the referenced Google Slides workshops but adapted
to the insurance domain.

https://claude.ai/code/session_01MLnStsm4YQNeGye3rc2BGH
</commit_message>
<xml_diff>
--- a/lecture_pptx/out/s11/ワーク01.pptx
+++ b/lecture_pptx/out/s11/ワーク01.pptx
@@ -1551,7 +1551,7 @@
                 <a:ea typeface="Yu Gothic UI Semibold" pitchFamily="34" charset="-122"/>
                 <a:cs typeface="Yu Gothic UI Semibold" pitchFamily="34" charset="-120"/>
               </a:rPr>
-              <a:t>公式LINE/Lステップ 設定 + シナリオ設計</a:t>
+              <a:t>LINE リッチメニュー × GAS チャットボット</a:t>
             </a:r>
             <a:endParaRPr lang="en-US" sz="3800" dirty="0"/>
           </a:p>
@@ -1590,7 +1590,7 @@
                 <a:ea typeface="Yu Gothic UI" pitchFamily="34" charset="-122"/>
                 <a:cs typeface="Yu Gothic UI" pitchFamily="34" charset="-120"/>
               </a:rPr>
-              <a:t>第10回の素材を本番稼働させ、興味度別シナリオまで一気に組み上げる</a:t>
+              <a:t>保険相談の入口を24時間動かす、自作チャットボットを完成させる</a:t>
             </a:r>
             <a:endParaRPr lang="en-US" sz="1900" dirty="0"/>
           </a:p>
@@ -1806,7 +1806,7 @@
                 <a:ea typeface="Yu Gothic UI Semibold" pitchFamily="34" charset="-122"/>
                 <a:cs typeface="Yu Gothic UI Semibold" pitchFamily="34" charset="-120"/>
               </a:rPr>
-              <a:t>公式LINE/Lステップを設定</a:t>
+              <a:t>チャットボット動線を設計</a:t>
             </a:r>
             <a:endParaRPr lang="en-US" sz="1700" dirty="0"/>
           </a:p>
@@ -1845,7 +1845,7 @@
                 <a:ea typeface="Yu Gothic UI" pitchFamily="34" charset="-122"/>
                 <a:cs typeface="Yu Gothic UI" pitchFamily="34" charset="-120"/>
               </a:rPr>
-              <a:t>第10回で固めた構成・素材を実機に流し込んで稼働状態にする。</a:t>
+              <a:t>リッチメニューのボタンから始まる会話の流れを設計する。</a:t>
             </a:r>
             <a:endParaRPr lang="en-US" sz="1300" dirty="0"/>
           </a:p>
@@ -1970,7 +1970,7 @@
                 <a:ea typeface="Yu Gothic UI Semibold" pitchFamily="34" charset="-122"/>
                 <a:cs typeface="Yu Gothic UI Semibold" pitchFamily="34" charset="-120"/>
               </a:rPr>
-              <a:t>興味度別シナリオ設計</a:t>
+              <a:t>GASでチャットボットを実装</a:t>
             </a:r>
             <a:endParaRPr lang="en-US" sz="1700" dirty="0"/>
           </a:p>
@@ -2009,7 +2009,7 @@
                 <a:ea typeface="Yu Gothic UI" pitchFamily="34" charset="-122"/>
                 <a:cs typeface="Yu Gothic UI" pitchFamily="34" charset="-120"/>
               </a:rPr>
-              <a:t>高/中/低 関心の3層別に配信動線を設計。</a:t>
+              <a:t>LINE Messaging API と GAS を接続、キーワードで返す仕組みを完成。</a:t>
             </a:r>
             <a:endParaRPr lang="en-US" sz="1300" dirty="0"/>
           </a:p>
@@ -2134,7 +2134,7 @@
                 <a:ea typeface="Yu Gothic UI Semibold" pitchFamily="34" charset="-122"/>
                 <a:cs typeface="Yu Gothic UI Semibold" pitchFamily="34" charset="-120"/>
               </a:rPr>
-              <a:t>本番運用前の確認</a:t>
+              <a:t>リッチメニューに接続</a:t>
             </a:r>
             <a:endParaRPr lang="en-US" sz="1700" dirty="0"/>
           </a:p>
@@ -2173,7 +2173,7 @@
                 <a:ea typeface="Yu Gothic UI" pitchFamily="34" charset="-122"/>
                 <a:cs typeface="Yu Gothic UI" pitchFamily="34" charset="-120"/>
               </a:rPr>
-              <a:t>タグ・セグメント・自動応答が想定通り動くかをテスト。</a:t>
+              <a:t>メニューのボタンからチャットボットが起動、実機で動作確認。</a:t>
             </a:r>
             <a:endParaRPr lang="en-US" sz="1300" dirty="0"/>
           </a:p>
@@ -2372,7 +2372,7 @@
                 <a:ea typeface="Yu Gothic UI Semibold" pitchFamily="34" charset="-122"/>
                 <a:cs typeface="Yu Gothic UI Semibold" pitchFamily="34" charset="-120"/>
               </a:rPr>
-              <a:t>公式LINE 設定</a:t>
+              <a:t>チャットボット</a:t>
             </a:r>
             <a:endParaRPr lang="en-US" sz="1600" dirty="0"/>
           </a:p>
@@ -2414,7 +2414,24 @@
                 <a:ea typeface="Yu Gothic UI" pitchFamily="34" charset="-122"/>
                 <a:cs typeface="Yu Gothic UI" pitchFamily="34" charset="-120"/>
               </a:rPr>
-              <a:t>プロフィール・あいさつ文・リッチメニュー・ステップ配信を全部入れて稼働させる作業。</a:t>
+              <a:t>LINE 上でユーザーの入力に対して自動で返答する仕組み。</a:t>
+            </a:r>
+            <a:pPr indent="0" marL="0">
+              <a:spcAft>
+                <a:spcPts val="600"/>
+              </a:spcAft>
+              <a:buNone/>
+            </a:pPr>
+            <a:r>
+              <a:rPr lang="en-US" sz="1600" dirty="0">
+                <a:solidFill>
+                  <a:srgbClr val="1A1A1A"/>
+                </a:solidFill>
+                <a:latin typeface="Yu Gothic UI" pitchFamily="34" charset="0"/>
+                <a:ea typeface="Yu Gothic UI" pitchFamily="34" charset="-122"/>
+                <a:cs typeface="Yu Gothic UI" pitchFamily="34" charset="-120"/>
+              </a:rPr>
+              <a:t>保険相談の一次受けに最適。</a:t>
             </a:r>
             <a:endParaRPr lang="en-US" sz="1600" dirty="0"/>
           </a:p>
@@ -2522,7 +2539,7 @@
                 <a:ea typeface="Yu Gothic UI Semibold" pitchFamily="34" charset="-122"/>
                 <a:cs typeface="Yu Gothic UI Semibold" pitchFamily="34" charset="-120"/>
               </a:rPr>
-              <a:t>Lステップ</a:t>
+              <a:t>LINE Messaging API</a:t>
             </a:r>
             <a:endParaRPr lang="en-US" sz="1600" dirty="0"/>
           </a:p>
@@ -2564,7 +2581,7 @@
                 <a:ea typeface="Yu Gothic UI" pitchFamily="34" charset="-122"/>
                 <a:cs typeface="Yu Gothic UI" pitchFamily="34" charset="-120"/>
               </a:rPr>
-              <a:t>公式LINE を拡張する外部ツール。</a:t>
+              <a:t>公式LINEを外部プログラム(GAS等)から操作するためのAPI。</a:t>
             </a:r>
             <a:pPr indent="0" marL="0">
               <a:spcAft>
@@ -2581,7 +2598,7 @@
                 <a:ea typeface="Yu Gothic UI" pitchFamily="34" charset="-122"/>
                 <a:cs typeface="Yu Gothic UI" pitchFamily="34" charset="-120"/>
               </a:rPr>
-              <a:t>タグ管理・分岐配信が強力。</a:t>
+              <a:t>メッセージ送信・受信ができる。</a:t>
             </a:r>
             <a:endParaRPr lang="en-US" sz="1600" dirty="0"/>
           </a:p>
@@ -2689,7 +2706,7 @@
                 <a:ea typeface="Yu Gothic UI Semibold" pitchFamily="34" charset="-122"/>
                 <a:cs typeface="Yu Gothic UI Semibold" pitchFamily="34" charset="-120"/>
               </a:rPr>
-              <a:t>タグ/セグメント</a:t>
+              <a:t>Webhook</a:t>
             </a:r>
             <a:endParaRPr lang="en-US" sz="1600" dirty="0"/>
           </a:p>
@@ -2731,7 +2748,24 @@
                 <a:ea typeface="Yu Gothic UI" pitchFamily="34" charset="-122"/>
                 <a:cs typeface="Yu Gothic UI" pitchFamily="34" charset="-120"/>
               </a:rPr>
-              <a:t>友だちを属性で分類して配信を出し分ける仕組み。</a:t>
+              <a:t>ユーザーがメッセージを送るとLINEが指定URLにデータを飛ばす仕組み。</a:t>
+            </a:r>
+            <a:pPr indent="0" marL="0">
+              <a:spcAft>
+                <a:spcPts val="600"/>
+              </a:spcAft>
+              <a:buNone/>
+            </a:pPr>
+            <a:r>
+              <a:rPr lang="en-US" sz="1600" dirty="0">
+                <a:solidFill>
+                  <a:srgbClr val="1A1A1A"/>
+                </a:solidFill>
+                <a:latin typeface="Yu Gothic UI" pitchFamily="34" charset="0"/>
+                <a:ea typeface="Yu Gothic UI" pitchFamily="34" charset="-122"/>
+                <a:cs typeface="Yu Gothic UI" pitchFamily="34" charset="-120"/>
+              </a:rPr>
+              <a:t>GASの公開URLを登録する。</a:t>
             </a:r>
             <a:endParaRPr lang="en-US" sz="1600" dirty="0"/>
           </a:p>
@@ -2839,7 +2873,7 @@
                 <a:ea typeface="Yu Gothic UI Semibold" pitchFamily="34" charset="-122"/>
                 <a:cs typeface="Yu Gothic UI Semibold" pitchFamily="34" charset="-120"/>
               </a:rPr>
-              <a:t>興味度</a:t>
+              <a:t>ポストバック</a:t>
             </a:r>
             <a:endParaRPr lang="en-US" sz="1600" dirty="0"/>
           </a:p>
@@ -2881,41 +2915,7 @@
                 <a:ea typeface="Yu Gothic UI" pitchFamily="34" charset="-122"/>
                 <a:cs typeface="Yu Gothic UI" pitchFamily="34" charset="-120"/>
               </a:rPr>
-              <a:t>友だちの関心度合い。</a:t>
-            </a:r>
-            <a:pPr indent="0" marL="0">
-              <a:spcAft>
-                <a:spcPts val="600"/>
-              </a:spcAft>
-              <a:buNone/>
-            </a:pPr>
-            <a:r>
-              <a:rPr lang="en-US" sz="1600" dirty="0">
-                <a:solidFill>
-                  <a:srgbClr val="1A1A1A"/>
-                </a:solidFill>
-                <a:latin typeface="Yu Gothic UI" pitchFamily="34" charset="0"/>
-                <a:ea typeface="Yu Gothic UI" pitchFamily="34" charset="-122"/>
-                <a:cs typeface="Yu Gothic UI" pitchFamily="34" charset="-120"/>
-              </a:rPr>
-              <a:t>高=予約に近い、低=情報収集段階。</a:t>
-            </a:r>
-            <a:pPr indent="0" marL="0">
-              <a:spcAft>
-                <a:spcPts val="600"/>
-              </a:spcAft>
-              <a:buNone/>
-            </a:pPr>
-            <a:r>
-              <a:rPr lang="en-US" sz="1600" dirty="0">
-                <a:solidFill>
-                  <a:srgbClr val="1A1A1A"/>
-                </a:solidFill>
-                <a:latin typeface="Yu Gothic UI" pitchFamily="34" charset="0"/>
-                <a:ea typeface="Yu Gothic UI" pitchFamily="34" charset="-122"/>
-                <a:cs typeface="Yu Gothic UI" pitchFamily="34" charset="-120"/>
-              </a:rPr>
-              <a:t>配信反応で推定。</a:t>
+              <a:t>リッチメニューやボタンをタップした時に、テキストではなく識別コードを送る仕組み。</a:t>
             </a:r>
             <a:endParaRPr lang="en-US" sz="1600" dirty="0"/>
           </a:p>
@@ -2968,7 +2968,7 @@
                 <a:ea typeface="Yu Gothic UI" pitchFamily="34" charset="-122"/>
                 <a:cs typeface="Yu Gothic UI" pitchFamily="34" charset="-120"/>
               </a:rPr>
-              <a:t>公式LINE 設定: </a:t>
+              <a:t>チャットボット: </a:t>
             </a:r>
             <a:pPr indent="0" marL="0">
               <a:buNone/>
@@ -2982,7 +2982,7 @@
                 <a:ea typeface="Yu Gothic UI" pitchFamily="34" charset="-122"/>
                 <a:cs typeface="Yu Gothic UI" pitchFamily="34" charset="-120"/>
               </a:rPr>
-              <a:t>管理画面とアプリで見え方が違うため両方確認   </a:t>
+              <a:t>24時間動く「入口」の役割   </a:t>
             </a:r>
             <a:pPr indent="0" marL="0">
               <a:buNone/>
@@ -3010,7 +3010,7 @@
                 <a:ea typeface="Yu Gothic UI" pitchFamily="34" charset="-122"/>
                 <a:cs typeface="Yu Gothic UI" pitchFamily="34" charset="-120"/>
               </a:rPr>
-              <a:t>Lステップ: </a:t>
+              <a:t>LINE Messaging API: </a:t>
             </a:r>
             <a:pPr indent="0" marL="0">
               <a:buNone/>
@@ -3024,7 +3024,7 @@
                 <a:ea typeface="Yu Gothic UI" pitchFamily="34" charset="-122"/>
                 <a:cs typeface="Yu Gothic UI" pitchFamily="34" charset="-120"/>
               </a:rPr>
-              <a:t>本格運用フェーズで導入を検討   </a:t>
+              <a:t>チャネルアクセストークンで認証   </a:t>
             </a:r>
             <a:pPr indent="0" marL="0">
               <a:buNone/>
@@ -3052,7 +3052,7 @@
                 <a:ea typeface="Yu Gothic UI" pitchFamily="34" charset="-122"/>
                 <a:cs typeface="Yu Gothic UI" pitchFamily="34" charset="-120"/>
               </a:rPr>
-              <a:t>タグ/セグメント: </a:t>
+              <a:t>Webhook: </a:t>
             </a:r>
             <a:pPr indent="0" marL="0">
               <a:buNone/>
@@ -3066,7 +3066,7 @@
                 <a:ea typeface="Yu Gothic UI" pitchFamily="34" charset="-122"/>
                 <a:cs typeface="Yu Gothic UI" pitchFamily="34" charset="-120"/>
               </a:rPr>
-              <a:t>登録経路や反応でタグ自動付与すると楽   </a:t>
+              <a:t>GASを「Webアプリとしてデプロイ」して使う   </a:t>
             </a:r>
             <a:pPr indent="0" marL="0">
               <a:buNone/>
@@ -3094,7 +3094,7 @@
                 <a:ea typeface="Yu Gothic UI" pitchFamily="34" charset="-122"/>
                 <a:cs typeface="Yu Gothic UI" pitchFamily="34" charset="-120"/>
               </a:rPr>
-              <a:t>興味度: </a:t>
+              <a:t>ポストバック: </a:t>
             </a:r>
             <a:pPr indent="0" marL="0">
               <a:buNone/>
@@ -3108,7 +3108,7 @@
                 <a:ea typeface="Yu Gothic UI" pitchFamily="34" charset="-122"/>
                 <a:cs typeface="Yu Gothic UI" pitchFamily="34" charset="-120"/>
               </a:rPr>
-              <a:t>層別に配信内容と頻度を変える</a:t>
+              <a:t>会話の分岐に使う</a:t>
             </a:r>
             <a:endParaRPr lang="en-US" sz="1100" dirty="0"/>
           </a:p>
@@ -3199,7 +3199,7 @@
                 <a:ea typeface="Yu Gothic UI Semibold" pitchFamily="34" charset="-122"/>
                 <a:cs typeface="Yu Gothic UI Semibold" pitchFamily="34" charset="-120"/>
               </a:rPr>
-              <a:t>演習1 公式LINE/Lステップ の本番設定</a:t>
+              <a:t>演習1 チャットボットの動線を設計</a:t>
             </a:r>
             <a:endParaRPr lang="en-US" sz="2600" dirty="0"/>
           </a:p>
@@ -3327,7 +3327,7 @@
                 <a:ea typeface="Yu Gothic UI" pitchFamily="34" charset="-122"/>
                 <a:cs typeface="Yu Gothic UI" pitchFamily="34" charset="-120"/>
               </a:rPr>
-              <a:t>第10回で「あいさつ文・リッチメニュー・LP URL」を作り、Day1〜3 のステップ配信本文も用意済み。</a:t>
+              <a:t>保険の問い合わせをLINEで24時間受けたい。リッチメニューのボタンから始まる会話の流れをまず紙 or スプシで設計する。</a:t>
             </a:r>
             <a:endParaRPr lang="en-US" sz="1400" dirty="0"/>
           </a:p>
@@ -3347,7 +3347,7 @@
                 <a:ea typeface="Yu Gothic UI" pitchFamily="34" charset="-122"/>
                 <a:cs typeface="Yu Gothic UI" pitchFamily="34" charset="-120"/>
               </a:rPr>
-              <a:t>これらを公式LINE(または Lステップ)に流し込んで、登録直後から配信が動く状態を完成させる。</a:t>
+              <a:t>コードを書く前に「何を聞いて、何を返すか」を固める。</a:t>
             </a:r>
             <a:endParaRPr lang="en-US" sz="1400" dirty="0"/>
           </a:p>
@@ -3476,7 +3476,7 @@
                 <a:ea typeface="Yu Gothic UI" pitchFamily="34" charset="-122"/>
                 <a:cs typeface="Yu Gothic UI" pitchFamily="34" charset="-120"/>
               </a:rPr>
-              <a:t>公式LINE Manager は manager.line.biz から、Lステップは別アカウント</a:t>
+              <a:t>Gemini に「保険営業のLINEチャットボット動線を6ボタンで設計」と依頼</a:t>
             </a:r>
             <a:endParaRPr lang="en-US" sz="1400" dirty="0"/>
           </a:p>
@@ -3497,7 +3497,7 @@
                 <a:ea typeface="Yu Gothic UI" pitchFamily="34" charset="-122"/>
                 <a:cs typeface="Yu Gothic UI" pitchFamily="34" charset="-120"/>
               </a:rPr>
-              <a:t>リッチメニューはタップ領域のズレに注意、必ずプレビュー</a:t>
+              <a:t>選択肢は3つまで(多いと迷う)</a:t>
             </a:r>
             <a:endParaRPr lang="en-US" sz="1400" dirty="0"/>
           </a:p>
@@ -3518,7 +3518,7 @@
                 <a:ea typeface="Yu Gothic UI" pitchFamily="34" charset="-122"/>
                 <a:cs typeface="Yu Gothic UI" pitchFamily="34" charset="-120"/>
               </a:rPr>
-              <a:t>ステップ配信のテストは「1分後」等に短縮して即確認</a:t>
+              <a:t>「AIに任せる範囲」と「人がやる範囲」の境界を決める</a:t>
             </a:r>
             <a:endParaRPr lang="en-US" sz="1400" dirty="0"/>
           </a:p>
@@ -3539,7 +3539,7 @@
                 <a:ea typeface="Yu Gothic UI" pitchFamily="34" charset="-122"/>
                 <a:cs typeface="Yu Gothic UI" pitchFamily="34" charset="-120"/>
               </a:rPr>
-              <a:t>本番設定に戻すのを忘れない(チェックリスト化)</a:t>
+              <a:t>設計はスプシで管理(コード化するときの仕様書になる)</a:t>
             </a:r>
             <a:endParaRPr lang="en-US" sz="1400" dirty="0"/>
           </a:p>
@@ -3668,7 +3668,7 @@
                 <a:ea typeface="Yu Gothic UI" pitchFamily="34" charset="-122"/>
                 <a:cs typeface="Yu Gothic UI" pitchFamily="34" charset="-120"/>
               </a:rPr>
-              <a:t>プロフィール画像・カバー・あいさつ文を最終設定</a:t>
+              <a:t>リッチメニューのボタン(3〜6個)ごとの目的を言語化(例: 保険の種類/資料請求/相談予約/よくある質問)</a:t>
             </a:r>
             <a:endParaRPr lang="en-US" sz="1400" dirty="0"/>
           </a:p>
@@ -3689,7 +3689,7 @@
                 <a:ea typeface="Yu Gothic UI" pitchFamily="34" charset="-122"/>
                 <a:cs typeface="Yu Gothic UI" pitchFamily="34" charset="-120"/>
               </a:rPr>
-              <a:t>リッチメニュー画像とタップ領域を全部割り当て</a:t>
+              <a:t>各ボタンをタップした時の「最初の返答」を1つずつ書く</a:t>
             </a:r>
             <a:endParaRPr lang="en-US" sz="1400" dirty="0"/>
           </a:p>
@@ -3710,7 +3710,7 @@
                 <a:ea typeface="Yu Gothic UI" pitchFamily="34" charset="-122"/>
                 <a:cs typeface="Yu Gothic UI" pitchFamily="34" charset="-120"/>
               </a:rPr>
-              <a:t>ステップ配信(Day1〜Day3)を登録+配信タイミング設定</a:t>
+              <a:t>3往復までの会話フローを図解(タップ→返答→選択肢→...)</a:t>
             </a:r>
             <a:endParaRPr lang="en-US" sz="1400" dirty="0"/>
           </a:p>
@@ -3731,28 +3731,7 @@
                 <a:ea typeface="Yu Gothic UI" pitchFamily="34" charset="-122"/>
                 <a:cs typeface="Yu Gothic UI" pitchFamily="34" charset="-120"/>
               </a:rPr>
-              <a:t>タグ(新規/名刺/既存)を作成し、登録経路で自動付与の設定</a:t>
-            </a:r>
-            <a:endParaRPr lang="en-US" sz="1400" dirty="0"/>
-          </a:p>
-          <a:p>
-            <a:pPr marL="342900" indent="-342900">
-              <a:spcAft>
-                <a:spcPts val="400"/>
-              </a:spcAft>
-              <a:buSzPct val="100000"/>
-              <a:buChar char="●"/>
-            </a:pPr>
-            <a:r>
-              <a:rPr lang="en-US" sz="1400" dirty="0">
-                <a:solidFill>
-                  <a:srgbClr val="1A1A1A"/>
-                </a:solidFill>
-                <a:latin typeface="Yu Gothic UI" pitchFamily="34" charset="0"/>
-                <a:ea typeface="Yu Gothic UI" pitchFamily="34" charset="-122"/>
-                <a:cs typeface="Yu Gothic UI" pitchFamily="34" charset="-120"/>
-              </a:rPr>
-              <a:t>テスト登録→Day1配信が届くまで実機で確認</a:t>
+              <a:t>最終ゴール(予約フォーム/資料DL/相談員に引き渡し)を明確化</a:t>
             </a:r>
             <a:endParaRPr lang="en-US" sz="1400" dirty="0"/>
           </a:p>
@@ -3843,7 +3822,7 @@
                 <a:ea typeface="Yu Gothic UI Semibold" pitchFamily="34" charset="-122"/>
                 <a:cs typeface="Yu Gothic UI Semibold" pitchFamily="34" charset="-120"/>
               </a:rPr>
-              <a:t>演習1 公式LINE/Lステップ の本番設定 — 観点別チェック</a:t>
+              <a:t>演習1 チャットボットの動線を設計 — 観点別チェック</a:t>
             </a:r>
             <a:endParaRPr lang="en-US" sz="2600" dirty="0"/>
           </a:p>
@@ -4007,7 +3986,7 @@
                 <a:ea typeface="Yu Gothic UI Semibold" pitchFamily="34" charset="-122"/>
                 <a:cs typeface="Yu Gothic UI Semibold" pitchFamily="34" charset="-120"/>
               </a:rPr>
-              <a:t>A. 設定漏れ</a:t>
+              <a:t>A. 分岐の必要性</a:t>
             </a:r>
             <a:endParaRPr lang="en-US" sz="1500" dirty="0"/>
           </a:p>
@@ -4060,7 +4039,7 @@
                 <a:ea typeface="Yu Gothic UI" pitchFamily="34" charset="-122"/>
                 <a:cs typeface="Yu Gothic UI" pitchFamily="34" charset="-120"/>
               </a:rPr>
-              <a:t>プロフィール/メニュー/配信/タグの4要素すべて設定したか</a:t>
+              <a:t>ボタン数が絞られ、選ぶ迷いがないか</a:t>
             </a:r>
             <a:endParaRPr lang="en-US" sz="1300" dirty="0"/>
           </a:p>
@@ -4113,7 +4092,7 @@
                 <a:ea typeface="Yu Gothic UI" pitchFamily="34" charset="-122"/>
                 <a:cs typeface="Yu Gothic UI" pitchFamily="34" charset="-120"/>
               </a:rPr>
-              <a:t>チェックリストで1個ずつ確認、口頭でなく文書で</a:t>
+              <a:t>6→4に減らす勇気、頻出だけ残す</a:t>
             </a:r>
             <a:endParaRPr lang="en-US" sz="1300" dirty="0"/>
           </a:p>
@@ -4238,7 +4217,7 @@
                 <a:ea typeface="Yu Gothic UI Semibold" pitchFamily="34" charset="-122"/>
                 <a:cs typeface="Yu Gothic UI Semibold" pitchFamily="34" charset="-120"/>
               </a:rPr>
-              <a:t>B. 動作確認の網羅性</a:t>
+              <a:t>B. 最終ゴールの明確化</a:t>
             </a:r>
             <a:endParaRPr lang="en-US" sz="1500" dirty="0"/>
           </a:p>
@@ -4291,7 +4270,7 @@
                 <a:ea typeface="Yu Gothic UI" pitchFamily="34" charset="-122"/>
                 <a:cs typeface="Yu Gothic UI" pitchFamily="34" charset="-120"/>
               </a:rPr>
-              <a:t>iOS と Android、PC ブラウザで見え方を確認したか</a:t>
+              <a:t>各フローが「予約 or 資料 or 人に繋ぐ」で終わるか</a:t>
             </a:r>
             <a:endParaRPr lang="en-US" sz="1300" dirty="0"/>
           </a:p>
@@ -4344,7 +4323,7 @@
                 <a:ea typeface="Yu Gothic UI" pitchFamily="34" charset="-122"/>
                 <a:cs typeface="Yu Gothic UI" pitchFamily="34" charset="-120"/>
               </a:rPr>
-              <a:t>実機3パターンでスクショ保存</a:t>
+              <a:t>ゴールなしフローはそもそも作らない</a:t>
             </a:r>
             <a:endParaRPr lang="en-US" sz="1300" dirty="0"/>
           </a:p>
@@ -4469,7 +4448,7 @@
                 <a:ea typeface="Yu Gothic UI Semibold" pitchFamily="34" charset="-122"/>
                 <a:cs typeface="Yu Gothic UI Semibold" pitchFamily="34" charset="-120"/>
               </a:rPr>
-              <a:t>C. タグ運用の準備度</a:t>
+              <a:t>C. 引き渡しの設計</a:t>
             </a:r>
             <a:endParaRPr lang="en-US" sz="1500" dirty="0"/>
           </a:p>
@@ -4522,7 +4501,7 @@
                 <a:ea typeface="Yu Gothic UI" pitchFamily="34" charset="-122"/>
                 <a:cs typeface="Yu Gothic UI" pitchFamily="34" charset="-120"/>
               </a:rPr>
-              <a:t>登録経路別にタグが自動付与されるか</a:t>
+              <a:t>難しい相談は「担当者に繋ぐ」に切り替わるか</a:t>
             </a:r>
             <a:endParaRPr lang="en-US" sz="1300" dirty="0"/>
           </a:p>
@@ -4575,7 +4554,7 @@
                 <a:ea typeface="Yu Gothic UI" pitchFamily="34" charset="-122"/>
                 <a:cs typeface="Yu Gothic UI" pitchFamily="34" charset="-120"/>
               </a:rPr>
-              <a:t>登録URLにパラメータを付けて分岐確認</a:t>
+              <a:t>AI万能視を避け、人にバトンを渡す仕組み</a:t>
             </a:r>
             <a:endParaRPr lang="en-US" sz="1300" dirty="0"/>
           </a:p>
@@ -4666,7 +4645,7 @@
                 <a:ea typeface="Yu Gothic UI Semibold" pitchFamily="34" charset="-122"/>
                 <a:cs typeface="Yu Gothic UI Semibold" pitchFamily="34" charset="-120"/>
               </a:rPr>
-              <a:t>演習2 興味度別シナリオを3層で設計</a:t>
+              <a:t>演習2 GASでチャットボットを構築+リッチメニューに接続</a:t>
             </a:r>
             <a:endParaRPr lang="en-US" sz="2600" dirty="0"/>
           </a:p>
@@ -4794,7 +4773,7 @@
                 <a:ea typeface="Yu Gothic UI" pitchFamily="34" charset="-122"/>
                 <a:cs typeface="Yu Gothic UI" pitchFamily="34" charset="-120"/>
               </a:rPr>
-              <a:t>本番が動き始めたら、配信内容を出し分けたくなる。高/中/低 関心の3層別に5日シナリオを設計。</a:t>
+              <a:t>設計した動線を GAS で実装する。LINE Messaging API のトークンを取得して、キーワード応答する最小構成のチャットボットをまず動かす。</a:t>
             </a:r>
             <a:endParaRPr lang="en-US" sz="1400" dirty="0"/>
           </a:p>
@@ -4923,7 +4902,7 @@
                 <a:ea typeface="Yu Gothic UI" pitchFamily="34" charset="-122"/>
                 <a:cs typeface="Yu Gothic UI" pitchFamily="34" charset="-120"/>
               </a:rPr>
-              <a:t>判定基準は「登録経路」「過去開封率」「リッチメニュー反応」等</a:t>
+              <a:t>Gemini に「LINE Messaging API と GAS でチャットボットを作るコード」を依頼</a:t>
             </a:r>
             <a:endParaRPr lang="en-US" sz="1400" dirty="0"/>
           </a:p>
@@ -4944,7 +4923,7 @@
                 <a:ea typeface="Yu Gothic UI" pitchFamily="34" charset="-122"/>
                 <a:cs typeface="Yu Gothic UI" pitchFamily="34" charset="-120"/>
               </a:rPr>
-              <a:t>Gemini に「保険営業の興味度別5日シナリオを3層で」と依頼</a:t>
+              <a:t>最初は「こんにちは」→「ようこそ」の1往復から</a:t>
             </a:r>
             <a:endParaRPr lang="en-US" sz="1400" dirty="0"/>
           </a:p>
@@ -4965,7 +4944,7 @@
                 <a:ea typeface="Yu Gothic UI" pitchFamily="34" charset="-122"/>
                 <a:cs typeface="Yu Gothic UI" pitchFamily="34" charset="-120"/>
               </a:rPr>
-              <a:t>各日のテーマは20文字以内のタイトルに</a:t>
+              <a:t>デプロイ時「アクセス許可: 全員」に注意(サンプルで確認)</a:t>
             </a:r>
             <a:endParaRPr lang="en-US" sz="1400" dirty="0"/>
           </a:p>
@@ -4986,7 +4965,7 @@
                 <a:ea typeface="Yu Gothic UI" pitchFamily="34" charset="-122"/>
                 <a:cs typeface="Yu Gothic UI" pitchFamily="34" charset="-120"/>
               </a:rPr>
-              <a:t>層毎のトーン(攻め/柔/教育)を変える</a:t>
+              <a:t>エラーは「LINE Developers &gt; Webhook 検証」でも確認できる</a:t>
             </a:r>
             <a:endParaRPr lang="en-US" sz="1400" dirty="0"/>
           </a:p>
@@ -5115,7 +5094,7 @@
                 <a:ea typeface="Yu Gothic UI" pitchFamily="34" charset="-122"/>
                 <a:cs typeface="Yu Gothic UI" pitchFamily="34" charset="-120"/>
               </a:rPr>
-              <a:t>高関心/中関心/低関心 の判定基準を1行ずつ言語化</a:t>
+              <a:t>LINE Developers でチャネルを作成 → アクセストークン取得</a:t>
             </a:r>
             <a:endParaRPr lang="en-US" sz="1400" dirty="0"/>
           </a:p>
@@ -5136,7 +5115,7 @@
                 <a:ea typeface="Yu Gothic UI" pitchFamily="34" charset="-122"/>
                 <a:cs typeface="Yu Gothic UI" pitchFamily="34" charset="-120"/>
               </a:rPr>
-              <a:t>各層別の5日分シナリオを表形式で作成</a:t>
+              <a:t>GAS に doPost 関数(Webhook 受信)を書き、返信するコードを実装</a:t>
             </a:r>
             <a:endParaRPr lang="en-US" sz="1400" dirty="0"/>
           </a:p>
@@ -5157,7 +5136,7 @@
                 <a:ea typeface="Yu Gothic UI" pitchFamily="34" charset="-122"/>
                 <a:cs typeface="Yu Gothic UI" pitchFamily="34" charset="-120"/>
               </a:rPr>
-              <a:t>層別の最終CV(予約/相談/資料請求等)を明確化</a:t>
+              <a:t>GAS を「ウェブアプリとしてデプロイ」→ 公開URL を LINE の Webhook に登録</a:t>
             </a:r>
             <a:endParaRPr lang="en-US" sz="1400" dirty="0"/>
           </a:p>
@@ -5178,7 +5157,28 @@
                 <a:ea typeface="Yu Gothic UI" pitchFamily="34" charset="-122"/>
                 <a:cs typeface="Yu Gothic UI" pitchFamily="34" charset="-120"/>
               </a:rPr>
-              <a:t>スプシで配信予定表として保存(次回の本文量産で使う)</a:t>
+              <a:t>リッチメニューのボタンにポストバック(識別コード)を設定</a:t>
+            </a:r>
+            <a:endParaRPr lang="en-US" sz="1400" dirty="0"/>
+          </a:p>
+          <a:p>
+            <a:pPr marL="342900" indent="-342900">
+              <a:spcAft>
+                <a:spcPts val="400"/>
+              </a:spcAft>
+              <a:buSzPct val="100000"/>
+              <a:buChar char="●"/>
+            </a:pPr>
+            <a:r>
+              <a:rPr lang="en-US" sz="1400" dirty="0">
+                <a:solidFill>
+                  <a:srgbClr val="1A1A1A"/>
+                </a:solidFill>
+                <a:latin typeface="Yu Gothic UI" pitchFamily="34" charset="0"/>
+                <a:ea typeface="Yu Gothic UI" pitchFamily="34" charset="-122"/>
+                <a:cs typeface="Yu Gothic UI" pitchFamily="34" charset="-120"/>
+              </a:rPr>
+              <a:t>自分のスマホからボタンをタップ → 応答が返るまで実機テスト</a:t>
             </a:r>
             <a:endParaRPr lang="en-US" sz="1400" dirty="0"/>
           </a:p>
@@ -5269,7 +5269,7 @@
                 <a:ea typeface="Yu Gothic UI Semibold" pitchFamily="34" charset="-122"/>
                 <a:cs typeface="Yu Gothic UI Semibold" pitchFamily="34" charset="-120"/>
               </a:rPr>
-              <a:t>演習2 興味度別シナリオを3層で設計 — 観点別チェック</a:t>
+              <a:t>演習2 GASでチャットボットを構築+リッチメニューに接続 — 観点別チェック</a:t>
             </a:r>
             <a:endParaRPr lang="en-US" sz="2600" dirty="0"/>
           </a:p>
@@ -5433,7 +5433,7 @@
                 <a:ea typeface="Yu Gothic UI Semibold" pitchFamily="34" charset="-122"/>
                 <a:cs typeface="Yu Gothic UI Semibold" pitchFamily="34" charset="-120"/>
               </a:rPr>
-              <a:t>A. 層の区別</a:t>
+              <a:t>A. トークン管理</a:t>
             </a:r>
             <a:endParaRPr lang="en-US" sz="1500" dirty="0"/>
           </a:p>
@@ -5486,7 +5486,7 @@
                 <a:ea typeface="Yu Gothic UI" pitchFamily="34" charset="-122"/>
                 <a:cs typeface="Yu Gothic UI" pitchFamily="34" charset="-120"/>
               </a:rPr>
-              <a:t>3層の違いが顧客の言動レベルで言語化できているか</a:t>
+              <a:t>チャネルアクセストークンをスクリプトプロパティに保存しているか</a:t>
             </a:r>
             <a:endParaRPr lang="en-US" sz="1300" dirty="0"/>
           </a:p>
@@ -5539,7 +5539,7 @@
                 <a:ea typeface="Yu Gothic UI" pitchFamily="34" charset="-122"/>
                 <a:cs typeface="Yu Gothic UI" pitchFamily="34" charset="-120"/>
               </a:rPr>
-              <a:t>層別に「典型的な行動例」を3つずつ書かせる</a:t>
+              <a:t>コードに直書き=事故の元、必ずプロパティに</a:t>
             </a:r>
             <a:endParaRPr lang="en-US" sz="1300" dirty="0"/>
           </a:p>
@@ -5664,7 +5664,7 @@
                 <a:ea typeface="Yu Gothic UI Semibold" pitchFamily="34" charset="-122"/>
                 <a:cs typeface="Yu Gothic UI Semibold" pitchFamily="34" charset="-120"/>
               </a:rPr>
-              <a:t>B. CV までの距離感</a:t>
+              <a:t>B. エラー時の挙動</a:t>
             </a:r>
             <a:endParaRPr lang="en-US" sz="1500" dirty="0"/>
           </a:p>
@@ -5717,7 +5717,7 @@
                 <a:ea typeface="Yu Gothic UI" pitchFamily="34" charset="-122"/>
                 <a:cs typeface="Yu Gothic UI" pitchFamily="34" charset="-120"/>
               </a:rPr>
-              <a:t>高=予約直球/低=信頼構築 と歩幅が違うか</a:t>
+              <a:t>想定外の入力で沈黙せず、案内文が返るか</a:t>
             </a:r>
             <a:endParaRPr lang="en-US" sz="1300" dirty="0"/>
           </a:p>
@@ -5770,7 +5770,7 @@
                 <a:ea typeface="Yu Gothic UI" pitchFamily="34" charset="-122"/>
                 <a:cs typeface="Yu Gothic UI" pitchFamily="34" charset="-120"/>
               </a:rPr>
-              <a:t>層別の "次の一歩" を1個に絞らせる</a:t>
+              <a:t>else 節に「ご質問は◯◯へ」と汎用返答を用意</a:t>
             </a:r>
             <a:endParaRPr lang="en-US" sz="1300" dirty="0"/>
           </a:p>
@@ -5895,7 +5895,7 @@
                 <a:ea typeface="Yu Gothic UI Semibold" pitchFamily="34" charset="-122"/>
                 <a:cs typeface="Yu Gothic UI Semibold" pitchFamily="34" charset="-120"/>
               </a:rPr>
-              <a:t>C. 配信頻度のバランス</a:t>
+              <a:t>C. 実機テスト</a:t>
             </a:r>
             <a:endParaRPr lang="en-US" sz="1500" dirty="0"/>
           </a:p>
@@ -5948,7 +5948,7 @@
                 <a:ea typeface="Yu Gothic UI" pitchFamily="34" charset="-122"/>
                 <a:cs typeface="Yu Gothic UI" pitchFamily="34" charset="-120"/>
               </a:rPr>
-              <a:t>層別に「うざくならない」配信間隔になっているか</a:t>
+              <a:t>PC のプレビューでなく自分のスマホで確認したか</a:t>
             </a:r>
             <a:endParaRPr lang="en-US" sz="1300" dirty="0"/>
           </a:p>
@@ -6001,7 +6001,7 @@
                 <a:ea typeface="Yu Gothic UI" pitchFamily="34" charset="-122"/>
                 <a:cs typeface="Yu Gothic UI" pitchFamily="34" charset="-120"/>
               </a:rPr>
-              <a:t>高=高頻度OK/低=月1〜2回 等を明示</a:t>
+              <a:t>実機でしか出ないバグ(絵文字/改行崩れ)を発見</a:t>
             </a:r>
             <a:endParaRPr lang="en-US" sz="1300" dirty="0"/>
           </a:p>
@@ -6197,7 +6197,7 @@
                 <a:ea typeface="Yu Gothic UI Semibold" pitchFamily="34" charset="-122"/>
                 <a:cs typeface="Yu Gothic UI Semibold" pitchFamily="34" charset="-120"/>
               </a:rPr>
-              <a:t>公式LINEが本番稼働</a:t>
+              <a:t>設計が9割</a:t>
             </a:r>
             <a:endParaRPr lang="en-US" sz="1800" dirty="0"/>
           </a:p>
@@ -6236,7 +6236,7 @@
                 <a:ea typeface="Yu Gothic UI" pitchFamily="34" charset="-122"/>
                 <a:cs typeface="Yu Gothic UI" pitchFamily="34" charset="-120"/>
               </a:rPr>
-              <a:t>第10回の素材が「動く仕組み」になり、登録→配信が自動で回る。</a:t>
+              <a:t>コードを書く前に、紙/スプシで動線を固めるとGAS実装は簡単。</a:t>
             </a:r>
             <a:endParaRPr lang="en-US" sz="1300" dirty="0"/>
           </a:p>
@@ -6341,7 +6341,7 @@
                 <a:ea typeface="Yu Gothic UI Semibold" pitchFamily="34" charset="-122"/>
                 <a:cs typeface="Yu Gothic UI Semibold" pitchFamily="34" charset="-120"/>
               </a:rPr>
-              <a:t>シナリオは出し分け</a:t>
+              <a:t>GAS × LINE で自作OK</a:t>
             </a:r>
             <a:endParaRPr lang="en-US" sz="1800" dirty="0"/>
           </a:p>
@@ -6380,7 +6380,7 @@
                 <a:ea typeface="Yu Gothic UI" pitchFamily="34" charset="-122"/>
                 <a:cs typeface="Yu Gothic UI" pitchFamily="34" charset="-120"/>
               </a:rPr>
-              <a:t>一律配信から卒業、興味度別の3層で開封率もCV率も改善。</a:t>
+              <a:t>ノーコードでなく、自分で書けると自由度が段違い。</a:t>
             </a:r>
             <a:endParaRPr lang="en-US" sz="1300" dirty="0"/>
           </a:p>
@@ -6485,7 +6485,7 @@
                 <a:ea typeface="Yu Gothic UI Semibold" pitchFamily="34" charset="-122"/>
                 <a:cs typeface="Yu Gothic UI Semibold" pitchFamily="34" charset="-120"/>
               </a:rPr>
-              <a:t>次は本文量産+分析</a:t>
+              <a:t>次はAI応答へ</a:t>
             </a:r>
             <a:endParaRPr lang="en-US" sz="1800" dirty="0"/>
           </a:p>
@@ -6524,7 +6524,7 @@
                 <a:ea typeface="Yu Gothic UI" pitchFamily="34" charset="-122"/>
                 <a:cs typeface="Yu Gothic UI" pitchFamily="34" charset="-120"/>
               </a:rPr>
-              <a:t>応用編で15通の本文をAIで一気に作り、ログ分析の習慣化へ。</a:t>
+              <a:t>応用編で Gemini API を組み込み、キーワード対応から自然対話へ進化。</a:t>
             </a:r>
             <a:endParaRPr lang="en-US" sz="1300" dirty="0"/>
           </a:p>

</xml_diff>

<commit_message>
Rework session 11 to match reference decks
Replace the wholly custom chatbot design with the actual two-part
lesson from the reference slides:
- ワーク01: Introduce アイテマス first, connect Google Calendar,
  set 面談 menus, then paste the booking URL into a rich-menu slot
  and inject it into the Lstep step-5 message.
- ワーク02: Collect FAQ knowledge into a spreadsheet, ask Gemini
  to write a GAS web app from that FAQ (バイブコーディング), deploy
  it as "anyone" so the URL is public, wire that URL to a rich-menu
  slot, and hand off unanswered questions to a staffer by email.

The chatbot is now correctly a deployed GAS web app whose URL sits
on the rich menu — not something running inside the rich menu.

https://claude.ai/code/session_01MLnStsm4YQNeGye3rc2BGH
</commit_message>
<xml_diff>
--- a/lecture_pptx/out/s11/ワーク01.pptx
+++ b/lecture_pptx/out/s11/ワーク01.pptx
@@ -1551,7 +1551,7 @@
                 <a:ea typeface="Yu Gothic UI Semibold" pitchFamily="34" charset="-122"/>
                 <a:cs typeface="Yu Gothic UI Semibold" pitchFamily="34" charset="-120"/>
               </a:rPr>
-              <a:t>LINE リッチメニュー × GAS チャットボット</a:t>
+              <a:t>アイテマス予約をリッチメニューに載せる</a:t>
             </a:r>
             <a:endParaRPr lang="en-US" sz="3800" dirty="0"/>
           </a:p>
@@ -1590,7 +1590,7 @@
                 <a:ea typeface="Yu Gothic UI" pitchFamily="34" charset="-122"/>
                 <a:cs typeface="Yu Gothic UI" pitchFamily="34" charset="-120"/>
               </a:rPr>
-              <a:t>保険相談の入口を24時間動かす、自作チャットボットを完成させる</a:t>
+              <a:t>LINE / L ステップの入口に「予約」ボタンを置いて取りこぼしをなくす</a:t>
             </a:r>
             <a:endParaRPr lang="en-US" sz="1900" dirty="0"/>
           </a:p>
@@ -1806,7 +1806,7 @@
                 <a:ea typeface="Yu Gothic UI Semibold" pitchFamily="34" charset="-122"/>
                 <a:cs typeface="Yu Gothic UI Semibold" pitchFamily="34" charset="-120"/>
               </a:rPr>
-              <a:t>チャットボット動線を設計</a:t>
+              <a:t>アイテマス空き枠を設定</a:t>
             </a:r>
             <a:endParaRPr lang="en-US" sz="1700" dirty="0"/>
           </a:p>
@@ -1845,7 +1845,7 @@
                 <a:ea typeface="Yu Gothic UI" pitchFamily="34" charset="-122"/>
                 <a:cs typeface="Yu Gothic UI" pitchFamily="34" charset="-120"/>
               </a:rPr>
-              <a:t>リッチメニューのボタンから始まる会話の流れを設計する。</a:t>
+              <a:t>アイテマスの面談メニューを作り、Google カレンダーと連携する。</a:t>
             </a:r>
             <a:endParaRPr lang="en-US" sz="1300" dirty="0"/>
           </a:p>
@@ -1970,7 +1970,7 @@
                 <a:ea typeface="Yu Gothic UI Semibold" pitchFamily="34" charset="-122"/>
                 <a:cs typeface="Yu Gothic UI Semibold" pitchFamily="34" charset="-120"/>
               </a:rPr>
-              <a:t>GASでチャットボットを実装</a:t>
+              <a:t>予約 URL をリッチメニューへ</a:t>
             </a:r>
             <a:endParaRPr lang="en-US" sz="1700" dirty="0"/>
           </a:p>
@@ -2009,7 +2009,7 @@
                 <a:ea typeface="Yu Gothic UI" pitchFamily="34" charset="-122"/>
                 <a:cs typeface="Yu Gothic UI" pitchFamily="34" charset="-120"/>
               </a:rPr>
-              <a:t>LINE Messaging API と GAS を接続、キーワードで返す仕組みを完成。</a:t>
+              <a:t>アイテマスの予約 URL を発行し、リッチメニューの1枠に紐付ける。</a:t>
             </a:r>
             <a:endParaRPr lang="en-US" sz="1300" dirty="0"/>
           </a:p>
@@ -2134,7 +2134,7 @@
                 <a:ea typeface="Yu Gothic UI Semibold" pitchFamily="34" charset="-122"/>
                 <a:cs typeface="Yu Gothic UI Semibold" pitchFamily="34" charset="-120"/>
               </a:rPr>
-              <a:t>リッチメニューに接続</a:t>
+              <a:t>L ステップからの導線設計</a:t>
             </a:r>
             <a:endParaRPr lang="en-US" sz="1700" dirty="0"/>
           </a:p>
@@ -2173,7 +2173,7 @@
                 <a:ea typeface="Yu Gothic UI" pitchFamily="34" charset="-122"/>
                 <a:cs typeface="Yu Gothic UI" pitchFamily="34" charset="-120"/>
               </a:rPr>
-              <a:t>メニューのボタンからチャットボットが起動、実機で動作確認。</a:t>
+              <a:t>ステップ配信のゴールに予約 URL を差し込み、24時間予約が入る仕組みに。</a:t>
             </a:r>
             <a:endParaRPr lang="en-US" sz="1300" dirty="0"/>
           </a:p>
@@ -2372,7 +2372,7 @@
                 <a:ea typeface="Yu Gothic UI Semibold" pitchFamily="34" charset="-122"/>
                 <a:cs typeface="Yu Gothic UI Semibold" pitchFamily="34" charset="-120"/>
               </a:rPr>
-              <a:t>チャットボット</a:t>
+              <a:t>アイテマス</a:t>
             </a:r>
             <a:endParaRPr lang="en-US" sz="1600" dirty="0"/>
           </a:p>
@@ -2414,7 +2414,7 @@
                 <a:ea typeface="Yu Gothic UI" pitchFamily="34" charset="-122"/>
                 <a:cs typeface="Yu Gothic UI" pitchFamily="34" charset="-120"/>
               </a:rPr>
-              <a:t>LINE 上でユーザーの入力に対して自動で返答する仕組み。</a:t>
+              <a:t>無料の日程調整ツール。</a:t>
             </a:r>
             <a:pPr indent="0" marL="0">
               <a:spcAft>
@@ -2431,7 +2431,24 @@
                 <a:ea typeface="Yu Gothic UI" pitchFamily="34" charset="-122"/>
                 <a:cs typeface="Yu Gothic UI" pitchFamily="34" charset="-120"/>
               </a:rPr>
-              <a:t>保険相談の一次受けに最適。</a:t>
+              <a:t>Googleカレンダー連携で空き枠を自動表示。</a:t>
+            </a:r>
+            <a:pPr indent="0" marL="0">
+              <a:spcAft>
+                <a:spcPts val="600"/>
+              </a:spcAft>
+              <a:buNone/>
+            </a:pPr>
+            <a:r>
+              <a:rPr lang="en-US" sz="1600" dirty="0">
+                <a:solidFill>
+                  <a:srgbClr val="1A1A1A"/>
+                </a:solidFill>
+                <a:latin typeface="Yu Gothic UI" pitchFamily="34" charset="0"/>
+                <a:ea typeface="Yu Gothic UI" pitchFamily="34" charset="-122"/>
+                <a:cs typeface="Yu Gothic UI" pitchFamily="34" charset="-120"/>
+              </a:rPr>
+              <a:t>共有URLで相手が予約できる。</a:t>
             </a:r>
             <a:endParaRPr lang="en-US" sz="1600" dirty="0"/>
           </a:p>
@@ -2539,7 +2556,7 @@
                 <a:ea typeface="Yu Gothic UI Semibold" pitchFamily="34" charset="-122"/>
                 <a:cs typeface="Yu Gothic UI Semibold" pitchFamily="34" charset="-120"/>
               </a:rPr>
-              <a:t>LINE Messaging API</a:t>
+              <a:t>予約 URL / QR</a:t>
             </a:r>
             <a:endParaRPr lang="en-US" sz="1600" dirty="0"/>
           </a:p>
@@ -2581,7 +2598,7 @@
                 <a:ea typeface="Yu Gothic UI" pitchFamily="34" charset="-122"/>
                 <a:cs typeface="Yu Gothic UI" pitchFamily="34" charset="-120"/>
               </a:rPr>
-              <a:t>公式LINEを外部プログラム(GAS等)から操作するためのAPI。</a:t>
+              <a:t>アイテマスが発行する予約ページのリンク。</a:t>
             </a:r>
             <a:pPr indent="0" marL="0">
               <a:spcAft>
@@ -2598,7 +2615,7 @@
                 <a:ea typeface="Yu Gothic UI" pitchFamily="34" charset="-122"/>
                 <a:cs typeface="Yu Gothic UI" pitchFamily="34" charset="-120"/>
               </a:rPr>
-              <a:t>メッセージ送信・受信ができる。</a:t>
+              <a:t>名刺・LP・LINE 全部に貼る「1つの URL」。</a:t>
             </a:r>
             <a:endParaRPr lang="en-US" sz="1600" dirty="0"/>
           </a:p>
@@ -2706,7 +2723,7 @@
                 <a:ea typeface="Yu Gothic UI Semibold" pitchFamily="34" charset="-122"/>
                 <a:cs typeface="Yu Gothic UI Semibold" pitchFamily="34" charset="-120"/>
               </a:rPr>
-              <a:t>Webhook</a:t>
+              <a:t>リッチメニュー</a:t>
             </a:r>
             <a:endParaRPr lang="en-US" sz="1600" dirty="0"/>
           </a:p>
@@ -2748,7 +2765,7 @@
                 <a:ea typeface="Yu Gothic UI" pitchFamily="34" charset="-122"/>
                 <a:cs typeface="Yu Gothic UI" pitchFamily="34" charset="-120"/>
               </a:rPr>
-              <a:t>ユーザーがメッセージを送るとLINEが指定URLにデータを飛ばす仕組み。</a:t>
+              <a:t>LINE 画面下部の常時表示ボタン(6分割 or 4分割)。</a:t>
             </a:r>
             <a:pPr indent="0" marL="0">
               <a:spcAft>
@@ -2765,7 +2782,7 @@
                 <a:ea typeface="Yu Gothic UI" pitchFamily="34" charset="-122"/>
                 <a:cs typeface="Yu Gothic UI" pitchFamily="34" charset="-120"/>
               </a:rPr>
-              <a:t>GASの公開URLを登録する。</a:t>
+              <a:t>1枠を「予約」に割り当てる。</a:t>
             </a:r>
             <a:endParaRPr lang="en-US" sz="1600" dirty="0"/>
           </a:p>
@@ -2873,7 +2890,7 @@
                 <a:ea typeface="Yu Gothic UI Semibold" pitchFamily="34" charset="-122"/>
                 <a:cs typeface="Yu Gothic UI Semibold" pitchFamily="34" charset="-120"/>
               </a:rPr>
-              <a:t>ポストバック</a:t>
+              <a:t>L ステップ連携</a:t>
             </a:r>
             <a:endParaRPr lang="en-US" sz="1600" dirty="0"/>
           </a:p>
@@ -2915,7 +2932,7 @@
                 <a:ea typeface="Yu Gothic UI" pitchFamily="34" charset="-122"/>
                 <a:cs typeface="Yu Gothic UI" pitchFamily="34" charset="-120"/>
               </a:rPr>
-              <a:t>リッチメニューやボタンをタップした時に、テキストではなく識別コードを送る仕組み。</a:t>
+              <a:t>ステップ配信の途中やゴールに予約 URL を差し込み、行動へ促す。</a:t>
             </a:r>
             <a:endParaRPr lang="en-US" sz="1600" dirty="0"/>
           </a:p>
@@ -2968,7 +2985,7 @@
                 <a:ea typeface="Yu Gothic UI" pitchFamily="34" charset="-122"/>
                 <a:cs typeface="Yu Gothic UI" pitchFamily="34" charset="-120"/>
               </a:rPr>
-              <a:t>チャットボット: </a:t>
+              <a:t>アイテマス: </a:t>
             </a:r>
             <a:pPr indent="0" marL="0">
               <a:buNone/>
@@ -2982,7 +2999,7 @@
                 <a:ea typeface="Yu Gothic UI" pitchFamily="34" charset="-122"/>
                 <a:cs typeface="Yu Gothic UI" pitchFamily="34" charset="-120"/>
               </a:rPr>
-              <a:t>24時間動く「入口」の役割   </a:t>
+              <a:t>itemasu.com で登録   </a:t>
             </a:r>
             <a:pPr indent="0" marL="0">
               <a:buNone/>
@@ -3010,7 +3027,7 @@
                 <a:ea typeface="Yu Gothic UI" pitchFamily="34" charset="-122"/>
                 <a:cs typeface="Yu Gothic UI" pitchFamily="34" charset="-120"/>
               </a:rPr>
-              <a:t>LINE Messaging API: </a:t>
+              <a:t>予約 URL / QR: </a:t>
             </a:r>
             <a:pPr indent="0" marL="0">
               <a:buNone/>
@@ -3024,7 +3041,7 @@
                 <a:ea typeface="Yu Gothic UI" pitchFamily="34" charset="-122"/>
                 <a:cs typeface="Yu Gothic UI" pitchFamily="34" charset="-120"/>
               </a:rPr>
-              <a:t>チャネルアクセストークンで認証   </a:t>
+              <a:t>QR コードでも共有可能   </a:t>
             </a:r>
             <a:pPr indent="0" marL="0">
               <a:buNone/>
@@ -3052,7 +3069,7 @@
                 <a:ea typeface="Yu Gothic UI" pitchFamily="34" charset="-122"/>
                 <a:cs typeface="Yu Gothic UI" pitchFamily="34" charset="-120"/>
               </a:rPr>
-              <a:t>Webhook: </a:t>
+              <a:t>リッチメニュー: </a:t>
             </a:r>
             <a:pPr indent="0" marL="0">
               <a:buNone/>
@@ -3066,7 +3083,7 @@
                 <a:ea typeface="Yu Gothic UI" pitchFamily="34" charset="-122"/>
                 <a:cs typeface="Yu Gothic UI" pitchFamily="34" charset="-120"/>
               </a:rPr>
-              <a:t>GASを「Webアプリとしてデプロイ」して使う   </a:t>
+              <a:t>第10回で設定済みの枠を使う   </a:t>
             </a:r>
             <a:pPr indent="0" marL="0">
               <a:buNone/>
@@ -3094,7 +3111,7 @@
                 <a:ea typeface="Yu Gothic UI" pitchFamily="34" charset="-122"/>
                 <a:cs typeface="Yu Gothic UI" pitchFamily="34" charset="-120"/>
               </a:rPr>
-              <a:t>ポストバック: </a:t>
+              <a:t>L ステップ連携: </a:t>
             </a:r>
             <a:pPr indent="0" marL="0">
               <a:buNone/>
@@ -3108,7 +3125,7 @@
                 <a:ea typeface="Yu Gothic UI" pitchFamily="34" charset="-122"/>
                 <a:cs typeface="Yu Gothic UI" pitchFamily="34" charset="-120"/>
               </a:rPr>
-              <a:t>会話の分岐に使う</a:t>
+              <a:t>「予約はこちら」の1文で十分</a:t>
             </a:r>
             <a:endParaRPr lang="en-US" sz="1100" dirty="0"/>
           </a:p>
@@ -3199,7 +3216,7 @@
                 <a:ea typeface="Yu Gothic UI Semibold" pitchFamily="34" charset="-122"/>
                 <a:cs typeface="Yu Gothic UI Semibold" pitchFamily="34" charset="-120"/>
               </a:rPr>
-              <a:t>演習1 チャットボットの動線を設計</a:t>
+              <a:t>演習1 アイテマス設定 → 予約 URL 発行</a:t>
             </a:r>
             <a:endParaRPr lang="en-US" sz="2600" dirty="0"/>
           </a:p>
@@ -3327,7 +3344,7 @@
                 <a:ea typeface="Yu Gothic UI" pitchFamily="34" charset="-122"/>
                 <a:cs typeface="Yu Gothic UI" pitchFamily="34" charset="-120"/>
               </a:rPr>
-              <a:t>保険の問い合わせをLINEで24時間受けたい。リッチメニューのボタンから始まる会話の流れをまず紙 or スプシで設計する。</a:t>
+              <a:t>前回作成した公式LINE にステップ配信までは動いているが、商談 or 面談 or 内見の予約はまだ手動(メール/電話)。</a:t>
             </a:r>
             <a:endParaRPr lang="en-US" sz="1400" dirty="0"/>
           </a:p>
@@ -3347,7 +3364,7 @@
                 <a:ea typeface="Yu Gothic UI" pitchFamily="34" charset="-122"/>
                 <a:cs typeface="Yu Gothic UI" pitchFamily="34" charset="-120"/>
               </a:rPr>
-              <a:t>コードを書く前に「何を聞いて、何を返すか」を固める。</a:t>
+              <a:t>日程調整ツールのアイテマスを導入して、24時間予約が入る仕組みを作る。</a:t>
             </a:r>
             <a:endParaRPr lang="en-US" sz="1400" dirty="0"/>
           </a:p>
@@ -3476,7 +3493,7 @@
                 <a:ea typeface="Yu Gothic UI" pitchFamily="34" charset="-122"/>
                 <a:cs typeface="Yu Gothic UI" pitchFamily="34" charset="-120"/>
               </a:rPr>
-              <a:t>Gemini に「保険営業のLINEチャットボット動線を6ボタンで設計」と依頼</a:t>
+              <a:t>対応時間は「本当に取れる時間」だけを設定(埋まりすぎ注意)</a:t>
             </a:r>
             <a:endParaRPr lang="en-US" sz="1400" dirty="0"/>
           </a:p>
@@ -3497,7 +3514,7 @@
                 <a:ea typeface="Yu Gothic UI" pitchFamily="34" charset="-122"/>
                 <a:cs typeface="Yu Gothic UI" pitchFamily="34" charset="-120"/>
               </a:rPr>
-              <a:t>選択肢は3つまで(多いと迷う)</a:t>
+              <a:t>面談メニューは種類を絞る(30分「無料相談」/60分「本格プラン相談」の2本が無難)</a:t>
             </a:r>
             <a:endParaRPr lang="en-US" sz="1400" dirty="0"/>
           </a:p>
@@ -3518,7 +3535,7 @@
                 <a:ea typeface="Yu Gothic UI" pitchFamily="34" charset="-122"/>
                 <a:cs typeface="Yu Gothic UI" pitchFamily="34" charset="-120"/>
               </a:rPr>
-              <a:t>「AIに任せる範囲」と「人がやる範囲」の境界を決める</a:t>
+              <a:t>テスト予約後は忘れずキャンセルする</a:t>
             </a:r>
             <a:endParaRPr lang="en-US" sz="1400" dirty="0"/>
           </a:p>
@@ -3539,7 +3556,7 @@
                 <a:ea typeface="Yu Gothic UI" pitchFamily="34" charset="-122"/>
                 <a:cs typeface="Yu Gothic UI" pitchFamily="34" charset="-120"/>
               </a:rPr>
-              <a:t>設計はスプシで管理(コード化するときの仕様書になる)</a:t>
+              <a:t>発行された URL は次の演習でリッチメニューに貼る</a:t>
             </a:r>
             <a:endParaRPr lang="en-US" sz="1400" dirty="0"/>
           </a:p>
@@ -3668,7 +3685,7 @@
                 <a:ea typeface="Yu Gothic UI" pitchFamily="34" charset="-122"/>
                 <a:cs typeface="Yu Gothic UI" pitchFamily="34" charset="-120"/>
               </a:rPr>
-              <a:t>リッチメニューのボタン(3〜6個)ごとの目的を言語化(例: 保険の種類/資料請求/相談予約/よくある質問)</a:t>
+              <a:t>アイテマスの無料アカウントを作成</a:t>
             </a:r>
             <a:endParaRPr lang="en-US" sz="1400" dirty="0"/>
           </a:p>
@@ -3689,7 +3706,7 @@
                 <a:ea typeface="Yu Gothic UI" pitchFamily="34" charset="-122"/>
                 <a:cs typeface="Yu Gothic UI" pitchFamily="34" charset="-120"/>
               </a:rPr>
-              <a:t>各ボタンをタップした時の「最初の返答」を1つずつ書く</a:t>
+              <a:t>Google カレンダーと連携し、既存予定を空き枠から除外</a:t>
             </a:r>
             <a:endParaRPr lang="en-US" sz="1400" dirty="0"/>
           </a:p>
@@ -3710,7 +3727,7 @@
                 <a:ea typeface="Yu Gothic UI" pitchFamily="34" charset="-122"/>
                 <a:cs typeface="Yu Gothic UI" pitchFamily="34" charset="-120"/>
               </a:rPr>
-              <a:t>3往復までの会話フローを図解(タップ→返答→選択肢→...)</a:t>
+              <a:t>面談メニュー(30分/60分など)を登録(対応時間帯・曜日を設定)</a:t>
             </a:r>
             <a:endParaRPr lang="en-US" sz="1400" dirty="0"/>
           </a:p>
@@ -3731,7 +3748,28 @@
                 <a:ea typeface="Yu Gothic UI" pitchFamily="34" charset="-122"/>
                 <a:cs typeface="Yu Gothic UI" pitchFamily="34" charset="-120"/>
               </a:rPr>
-              <a:t>最終ゴール(予約フォーム/資料DL/相談員に引き渡し)を明確化</a:t>
+              <a:t>予約ページ URL(または QR)を発行</a:t>
+            </a:r>
+            <a:endParaRPr lang="en-US" sz="1400" dirty="0"/>
+          </a:p>
+          <a:p>
+            <a:pPr marL="342900" indent="-342900">
+              <a:spcAft>
+                <a:spcPts val="400"/>
+              </a:spcAft>
+              <a:buSzPct val="100000"/>
+              <a:buChar char="●"/>
+            </a:pPr>
+            <a:r>
+              <a:rPr lang="en-US" sz="1400" dirty="0">
+                <a:solidFill>
+                  <a:srgbClr val="1A1A1A"/>
+                </a:solidFill>
+                <a:latin typeface="Yu Gothic UI" pitchFamily="34" charset="0"/>
+                <a:ea typeface="Yu Gothic UI" pitchFamily="34" charset="-122"/>
+                <a:cs typeface="Yu Gothic UI" pitchFamily="34" charset="-120"/>
+              </a:rPr>
+              <a:t>テスト予約を1件入れて、Google カレンダーに追加されるかを確認</a:t>
             </a:r>
             <a:endParaRPr lang="en-US" sz="1400" dirty="0"/>
           </a:p>
@@ -3822,7 +3860,7 @@
                 <a:ea typeface="Yu Gothic UI Semibold" pitchFamily="34" charset="-122"/>
                 <a:cs typeface="Yu Gothic UI Semibold" pitchFamily="34" charset="-120"/>
               </a:rPr>
-              <a:t>演習1 チャットボットの動線を設計 — 観点別チェック</a:t>
+              <a:t>演習1 アイテマス設定 → 予約 URL 発行 — 観点別チェック</a:t>
             </a:r>
             <a:endParaRPr lang="en-US" sz="2600" dirty="0"/>
           </a:p>
@@ -3986,7 +4024,7 @@
                 <a:ea typeface="Yu Gothic UI Semibold" pitchFamily="34" charset="-122"/>
                 <a:cs typeface="Yu Gothic UI Semibold" pitchFamily="34" charset="-120"/>
               </a:rPr>
-              <a:t>A. 分岐の必要性</a:t>
+              <a:t>A. 空き枠の妥当性</a:t>
             </a:r>
             <a:endParaRPr lang="en-US" sz="1500" dirty="0"/>
           </a:p>
@@ -4039,7 +4077,7 @@
                 <a:ea typeface="Yu Gothic UI" pitchFamily="34" charset="-122"/>
                 <a:cs typeface="Yu Gothic UI" pitchFamily="34" charset="-120"/>
               </a:rPr>
-              <a:t>ボタン数が絞られ、選ぶ迷いがないか</a:t>
+              <a:t>アイテマス上の空き枠が「実際に取れる時間」に一致しているか</a:t>
             </a:r>
             <a:endParaRPr lang="en-US" sz="1300" dirty="0"/>
           </a:p>
@@ -4092,7 +4130,7 @@
                 <a:ea typeface="Yu Gothic UI" pitchFamily="34" charset="-122"/>
                 <a:cs typeface="Yu Gothic UI" pitchFamily="34" charset="-120"/>
               </a:rPr>
-              <a:t>6→4に減らす勇気、頻出だけ残す</a:t>
+              <a:t>Googleカレンダーの繁忙時間もブロック済みか確認</a:t>
             </a:r>
             <a:endParaRPr lang="en-US" sz="1300" dirty="0"/>
           </a:p>
@@ -4217,7 +4255,7 @@
                 <a:ea typeface="Yu Gothic UI Semibold" pitchFamily="34" charset="-122"/>
                 <a:cs typeface="Yu Gothic UI Semibold" pitchFamily="34" charset="-120"/>
               </a:rPr>
-              <a:t>B. 最終ゴールの明確化</a:t>
+              <a:t>B. メニュー数の絞り込み</a:t>
             </a:r>
             <a:endParaRPr lang="en-US" sz="1500" dirty="0"/>
           </a:p>
@@ -4270,7 +4308,7 @@
                 <a:ea typeface="Yu Gothic UI" pitchFamily="34" charset="-122"/>
                 <a:cs typeface="Yu Gothic UI" pitchFamily="34" charset="-120"/>
               </a:rPr>
-              <a:t>各フローが「予約 or 資料 or 人に繋ぐ」で終わるか</a:t>
+              <a:t>面談メニューが 2〜3種類に収まっているか</a:t>
             </a:r>
             <a:endParaRPr lang="en-US" sz="1300" dirty="0"/>
           </a:p>
@@ -4323,7 +4361,7 @@
                 <a:ea typeface="Yu Gothic UI" pitchFamily="34" charset="-122"/>
                 <a:cs typeface="Yu Gothic UI" pitchFamily="34" charset="-120"/>
               </a:rPr>
-              <a:t>ゴールなしフローはそもそも作らない</a:t>
+              <a:t>多すぎると顧客が迷う、まず 2 種類から</a:t>
             </a:r>
             <a:endParaRPr lang="en-US" sz="1300" dirty="0"/>
           </a:p>
@@ -4448,7 +4486,7 @@
                 <a:ea typeface="Yu Gothic UI Semibold" pitchFamily="34" charset="-122"/>
                 <a:cs typeface="Yu Gothic UI Semibold" pitchFamily="34" charset="-120"/>
               </a:rPr>
-              <a:t>C. 引き渡しの設計</a:t>
+              <a:t>C. 連携テスト</a:t>
             </a:r>
             <a:endParaRPr lang="en-US" sz="1500" dirty="0"/>
           </a:p>
@@ -4501,7 +4539,7 @@
                 <a:ea typeface="Yu Gothic UI" pitchFamily="34" charset="-122"/>
                 <a:cs typeface="Yu Gothic UI" pitchFamily="34" charset="-120"/>
               </a:rPr>
-              <a:t>難しい相談は「担当者に繋ぐ」に切り替わるか</a:t>
+              <a:t>テスト予約でカレンダーに追加+通知が届いているか</a:t>
             </a:r>
             <a:endParaRPr lang="en-US" sz="1300" dirty="0"/>
           </a:p>
@@ -4554,7 +4592,7 @@
                 <a:ea typeface="Yu Gothic UI" pitchFamily="34" charset="-122"/>
                 <a:cs typeface="Yu Gothic UI" pitchFamily="34" charset="-120"/>
               </a:rPr>
-              <a:t>AI万能視を避け、人にバトンを渡す仕組み</a:t>
+              <a:t>メール/LINE 両方の通知設定を確認</a:t>
             </a:r>
             <a:endParaRPr lang="en-US" sz="1300" dirty="0"/>
           </a:p>
@@ -4645,7 +4683,7 @@
                 <a:ea typeface="Yu Gothic UI Semibold" pitchFamily="34" charset="-122"/>
                 <a:cs typeface="Yu Gothic UI Semibold" pitchFamily="34" charset="-120"/>
               </a:rPr>
-              <a:t>演習2 GASでチャットボットを構築+リッチメニューに接続</a:t>
+              <a:t>演習2 リッチメニューに予約 URL を貼る + Lステップ配信に組み込む</a:t>
             </a:r>
             <a:endParaRPr lang="en-US" sz="2600" dirty="0"/>
           </a:p>
@@ -4773,7 +4811,7 @@
                 <a:ea typeface="Yu Gothic UI" pitchFamily="34" charset="-122"/>
                 <a:cs typeface="Yu Gothic UI" pitchFamily="34" charset="-120"/>
               </a:rPr>
-              <a:t>設計した動線を GAS で実装する。LINE Messaging API のトークンを取得して、キーワード応答する最小構成のチャットボットをまず動かす。</a:t>
+              <a:t>発行したアイテマスの予約 URL を、リッチメニューの1枠と Lステップ配信の中に差し込んで、「どこからでも予約できる」導線にする。</a:t>
             </a:r>
             <a:endParaRPr lang="en-US" sz="1400" dirty="0"/>
           </a:p>
@@ -4902,7 +4940,7 @@
                 <a:ea typeface="Yu Gothic UI" pitchFamily="34" charset="-122"/>
                 <a:cs typeface="Yu Gothic UI" pitchFamily="34" charset="-120"/>
               </a:rPr>
-              <a:t>Gemini に「LINE Messaging API と GAS でチャットボットを作るコード」を依頼</a:t>
+              <a:t>予約ボタンの文言は「無料相談を予約」など柔らかく</a:t>
             </a:r>
             <a:endParaRPr lang="en-US" sz="1400" dirty="0"/>
           </a:p>
@@ -4923,7 +4961,7 @@
                 <a:ea typeface="Yu Gothic UI" pitchFamily="34" charset="-122"/>
                 <a:cs typeface="Yu Gothic UI" pitchFamily="34" charset="-120"/>
               </a:rPr>
-              <a:t>最初は「こんにちは」→「ようこそ」の1往復から</a:t>
+              <a:t>ステップ配信本文は「予約はこちら 👉 &lt;URL&gt;」の1文で十分</a:t>
             </a:r>
             <a:endParaRPr lang="en-US" sz="1400" dirty="0"/>
           </a:p>
@@ -4944,7 +4982,7 @@
                 <a:ea typeface="Yu Gothic UI" pitchFamily="34" charset="-122"/>
                 <a:cs typeface="Yu Gothic UI" pitchFamily="34" charset="-120"/>
               </a:rPr>
-              <a:t>デプロイ時「アクセス許可: 全員」に注意(サンプルで確認)</a:t>
+              <a:t>予約導線は LINE 内で完結させる(外部離脱を避ける)</a:t>
             </a:r>
             <a:endParaRPr lang="en-US" sz="1400" dirty="0"/>
           </a:p>
@@ -4965,7 +5003,7 @@
                 <a:ea typeface="Yu Gothic UI" pitchFamily="34" charset="-122"/>
                 <a:cs typeface="Yu Gothic UI" pitchFamily="34" charset="-120"/>
               </a:rPr>
-              <a:t>エラーは「LINE Developers &gt; Webhook 検証」でも確認できる</a:t>
+              <a:t>取りこぼし防止のため、複数箇所(リッチメニュー + 配信2箇所)に貼る</a:t>
             </a:r>
             <a:endParaRPr lang="en-US" sz="1400" dirty="0"/>
           </a:p>
@@ -5094,7 +5132,7 @@
                 <a:ea typeface="Yu Gothic UI" pitchFamily="34" charset="-122"/>
                 <a:cs typeface="Yu Gothic UI" pitchFamily="34" charset="-120"/>
               </a:rPr>
-              <a:t>LINE Developers でチャネルを作成 → アクセストークン取得</a:t>
+              <a:t>リッチメニュー6枠のラベル設計(1枠は必ず「予約」)</a:t>
             </a:r>
             <a:endParaRPr lang="en-US" sz="1400" dirty="0"/>
           </a:p>
@@ -5115,7 +5153,7 @@
                 <a:ea typeface="Yu Gothic UI" pitchFamily="34" charset="-122"/>
                 <a:cs typeface="Yu Gothic UI" pitchFamily="34" charset="-120"/>
               </a:rPr>
-              <a:t>GAS に doPost 関数(Webhook 受信)を書き、返信するコードを実装</a:t>
+              <a:t>第10回で作ったリッチメニュー画像の1枠に、URL アクションで予約 URL を設定</a:t>
             </a:r>
             <a:endParaRPr lang="en-US" sz="1400" dirty="0"/>
           </a:p>
@@ -5136,7 +5174,7 @@
                 <a:ea typeface="Yu Gothic UI" pitchFamily="34" charset="-122"/>
                 <a:cs typeface="Yu Gothic UI" pitchFamily="34" charset="-120"/>
               </a:rPr>
-              <a:t>GAS を「ウェブアプリとしてデプロイ」→ 公開URL を LINE の Webhook に登録</a:t>
+              <a:t>Lステップ(または公式LINE)のステップ配信 Day5(行動)に予約 URL を差し込み</a:t>
             </a:r>
             <a:endParaRPr lang="en-US" sz="1400" dirty="0"/>
           </a:p>
@@ -5157,7 +5195,7 @@
                 <a:ea typeface="Yu Gothic UI" pitchFamily="34" charset="-122"/>
                 <a:cs typeface="Yu Gothic UI" pitchFamily="34" charset="-120"/>
               </a:rPr>
-              <a:t>リッチメニューのボタンにポストバック(識別コード)を設定</a:t>
+              <a:t>自分のスマホでリッチメニュー「予約」ボタンをタップ → アイテマスが開くか確認</a:t>
             </a:r>
             <a:endParaRPr lang="en-US" sz="1400" dirty="0"/>
           </a:p>
@@ -5178,7 +5216,7 @@
                 <a:ea typeface="Yu Gothic UI" pitchFamily="34" charset="-122"/>
                 <a:cs typeface="Yu Gothic UI" pitchFamily="34" charset="-120"/>
               </a:rPr>
-              <a:t>自分のスマホからボタンをタップ → 応答が返るまで実機テスト</a:t>
+              <a:t>Lステップ配信中のリンクからも予約ページに遷移するかを確認</a:t>
             </a:r>
             <a:endParaRPr lang="en-US" sz="1400" dirty="0"/>
           </a:p>
@@ -5269,7 +5307,7 @@
                 <a:ea typeface="Yu Gothic UI Semibold" pitchFamily="34" charset="-122"/>
                 <a:cs typeface="Yu Gothic UI Semibold" pitchFamily="34" charset="-120"/>
               </a:rPr>
-              <a:t>演習2 GASでチャットボットを構築+リッチメニューに接続 — 観点別チェック</a:t>
+              <a:t>演習2 リッチメニューに予約 URL を貼る + Lステップ配信に組み込む — 観点別チェック</a:t>
             </a:r>
             <a:endParaRPr lang="en-US" sz="2600" dirty="0"/>
           </a:p>
@@ -5433,7 +5471,7 @@
                 <a:ea typeface="Yu Gothic UI Semibold" pitchFamily="34" charset="-122"/>
                 <a:cs typeface="Yu Gothic UI Semibold" pitchFamily="34" charset="-120"/>
               </a:rPr>
-              <a:t>A. トークン管理</a:t>
+              <a:t>A. 予約枠の目立ち</a:t>
             </a:r>
             <a:endParaRPr lang="en-US" sz="1500" dirty="0"/>
           </a:p>
@@ -5486,7 +5524,7 @@
                 <a:ea typeface="Yu Gothic UI" pitchFamily="34" charset="-122"/>
                 <a:cs typeface="Yu Gothic UI" pitchFamily="34" charset="-120"/>
               </a:rPr>
-              <a:t>チャネルアクセストークンをスクリプトプロパティに保存しているか</a:t>
+              <a:t>6枠中「予約」ボタンが視覚的に一番目立つか</a:t>
             </a:r>
             <a:endParaRPr lang="en-US" sz="1300" dirty="0"/>
           </a:p>
@@ -5539,7 +5577,7 @@
                 <a:ea typeface="Yu Gothic UI" pitchFamily="34" charset="-122"/>
                 <a:cs typeface="Yu Gothic UI" pitchFamily="34" charset="-120"/>
               </a:rPr>
-              <a:t>コードに直書き=事故の元、必ずプロパティに</a:t>
+              <a:t>色/絵文字/ラベルで差をつける</a:t>
             </a:r>
             <a:endParaRPr lang="en-US" sz="1300" dirty="0"/>
           </a:p>
@@ -5664,7 +5702,7 @@
                 <a:ea typeface="Yu Gothic UI Semibold" pitchFamily="34" charset="-122"/>
                 <a:cs typeface="Yu Gothic UI Semibold" pitchFamily="34" charset="-120"/>
               </a:rPr>
-              <a:t>B. エラー時の挙動</a:t>
+              <a:t>B. 配信内での差し込み</a:t>
             </a:r>
             <a:endParaRPr lang="en-US" sz="1500" dirty="0"/>
           </a:p>
@@ -5717,7 +5755,7 @@
                 <a:ea typeface="Yu Gothic UI" pitchFamily="34" charset="-122"/>
                 <a:cs typeface="Yu Gothic UI" pitchFamily="34" charset="-120"/>
               </a:rPr>
-              <a:t>想定外の入力で沈黙せず、案内文が返るか</a:t>
+              <a:t>Day5(行動)以外にも予約 URL の伏線があるか</a:t>
             </a:r>
             <a:endParaRPr lang="en-US" sz="1300" dirty="0"/>
           </a:p>
@@ -5770,7 +5808,7 @@
                 <a:ea typeface="Yu Gothic UI" pitchFamily="34" charset="-122"/>
                 <a:cs typeface="Yu Gothic UI" pitchFamily="34" charset="-120"/>
               </a:rPr>
-              <a:t>else 節に「ご質問は◯◯へ」と汎用返答を用意</a:t>
+              <a:t>Day3(欲求)などにも軽く触れておく</a:t>
             </a:r>
             <a:endParaRPr lang="en-US" sz="1300" dirty="0"/>
           </a:p>
@@ -5895,7 +5933,7 @@
                 <a:ea typeface="Yu Gothic UI Semibold" pitchFamily="34" charset="-122"/>
                 <a:cs typeface="Yu Gothic UI Semibold" pitchFamily="34" charset="-120"/>
               </a:rPr>
-              <a:t>C. 実機テスト</a:t>
+              <a:t>C. 遷移テスト</a:t>
             </a:r>
             <a:endParaRPr lang="en-US" sz="1500" dirty="0"/>
           </a:p>
@@ -5948,7 +5986,7 @@
                 <a:ea typeface="Yu Gothic UI" pitchFamily="34" charset="-122"/>
                 <a:cs typeface="Yu Gothic UI" pitchFamily="34" charset="-120"/>
               </a:rPr>
-              <a:t>PC のプレビューでなく自分のスマホで確認したか</a:t>
+              <a:t>リッチメニュー/配信 双方から URL 遷移確認したか</a:t>
             </a:r>
             <a:endParaRPr lang="en-US" sz="1300" dirty="0"/>
           </a:p>
@@ -6001,7 +6039,7 @@
                 <a:ea typeface="Yu Gothic UI" pitchFamily="34" charset="-122"/>
                 <a:cs typeface="Yu Gothic UI" pitchFamily="34" charset="-120"/>
               </a:rPr>
-              <a:t>実機でしか出ないバグ(絵文字/改行崩れ)を発見</a:t>
+              <a:t>実機でスマホから必ずテスト</a:t>
             </a:r>
             <a:endParaRPr lang="en-US" sz="1300" dirty="0"/>
           </a:p>
@@ -6197,7 +6235,7 @@
                 <a:ea typeface="Yu Gothic UI Semibold" pitchFamily="34" charset="-122"/>
                 <a:cs typeface="Yu Gothic UI Semibold" pitchFamily="34" charset="-120"/>
               </a:rPr>
-              <a:t>設計が9割</a:t>
+              <a:t>予約は24時間動く導線に</a:t>
             </a:r>
             <a:endParaRPr lang="en-US" sz="1800" dirty="0"/>
           </a:p>
@@ -6236,7 +6274,7 @@
                 <a:ea typeface="Yu Gothic UI" pitchFamily="34" charset="-122"/>
                 <a:cs typeface="Yu Gothic UI" pitchFamily="34" charset="-120"/>
               </a:rPr>
-              <a:t>コードを書く前に、紙/スプシで動線を固めるとGAS実装は簡単。</a:t>
+              <a:t>アイテマスで、電話/メール待ちの機会損失を防ぐ。</a:t>
             </a:r>
             <a:endParaRPr lang="en-US" sz="1300" dirty="0"/>
           </a:p>
@@ -6341,7 +6379,7 @@
                 <a:ea typeface="Yu Gothic UI Semibold" pitchFamily="34" charset="-122"/>
                 <a:cs typeface="Yu Gothic UI Semibold" pitchFamily="34" charset="-120"/>
               </a:rPr>
-              <a:t>GAS × LINE で自作OK</a:t>
+              <a:t>リッチメニューの1枠は必ず「予約」</a:t>
             </a:r>
             <a:endParaRPr lang="en-US" sz="1800" dirty="0"/>
           </a:p>
@@ -6380,7 +6418,7 @@
                 <a:ea typeface="Yu Gothic UI" pitchFamily="34" charset="-122"/>
                 <a:cs typeface="Yu Gothic UI" pitchFamily="34" charset="-120"/>
               </a:rPr>
-              <a:t>ノーコードでなく、自分で書けると自由度が段違い。</a:t>
+              <a:t>常時表示される「予約」ボタンが取りこぼしをなくす。</a:t>
             </a:r>
             <a:endParaRPr lang="en-US" sz="1300" dirty="0"/>
           </a:p>
@@ -6485,7 +6523,7 @@
                 <a:ea typeface="Yu Gothic UI Semibold" pitchFamily="34" charset="-122"/>
                 <a:cs typeface="Yu Gothic UI Semibold" pitchFamily="34" charset="-120"/>
               </a:rPr>
-              <a:t>次はAI応答へ</a:t>
+              <a:t>配信のゴールは予約 URL で締める</a:t>
             </a:r>
             <a:endParaRPr lang="en-US" sz="1800" dirty="0"/>
           </a:p>
@@ -6524,7 +6562,7 @@
                 <a:ea typeface="Yu Gothic UI" pitchFamily="34" charset="-122"/>
                 <a:cs typeface="Yu Gothic UI" pitchFamily="34" charset="-120"/>
               </a:rPr>
-              <a:t>応用編で Gemini API を組み込み、キーワード対応から自然対話へ進化。</a:t>
+              <a:t>ステップ配信 Day5 に必ず予約 URL を差し込む。</a:t>
             </a:r>
             <a:endParaRPr lang="en-US" sz="1300" dirty="0"/>
           </a:p>

</xml_diff>